<commit_message>
docs(paper): use the application's catalysis vocabulary in the note, figures and SI
The manuscript said "order size", "procedure" and "dated prices" where the
application itself shows "Production scale" and "Preparation method" and where
catalysis readers expect those terms. The note, Figure 2(a), Figure 4(b), the
SI and the Table of Contents graphic now use production scale (defined once as
the catalyst mass of one order), preparation method and metal price histories.
Numbers are unchanged; the count is 4,997 of 5,000 by Word's own statistic.

Audit entry H57.

Co-Authored-By: Claude Fable 5.1 <noreply@anthropic.com>
</commit_message>
<xml_diff>
--- a/docs/paper/diagram-sources-2026-09-16/fig2_cost_model.pptx
+++ b/docs/paper/diagram-sources-2026-09-16/fig2_cost_model.pptx
@@ -3721,8 +3721,8 @@
         </p:nvSpPr>
         <p:spPr>
           <a:xfrm>
-            <a:off x="144000" y="1915200"/>
-            <a:ext cx="2196000" cy="180000"/>
+            <a:off x="-899100" y="1915200"/>
+            <a:ext cx="4282200" cy="180000"/>
           </a:xfrm>
           <a:prstGeom prst="rect">
             <a:avLst/>
@@ -3757,7 +3757,7 @@
                 <a:ea typeface="Arial"/>
                 <a:cs typeface="Arial"/>
               </a:rPr>
-              <a:t>Route and order size</a:t>
+              <a:t>Preparation method and production scale</a:t>
             </a:r>
           </a:p>
         </p:txBody>
@@ -4703,7 +4703,7 @@
                 <a:ea typeface="Malgun Gothic"/>
                 <a:cs typeface="Malgun Gothic"/>
               </a:rPr>
-              <a:t>제조 경로 및 주문량</a:t>
+              <a:t>제조법 및 생산 규모</a:t>
             </a:r>
           </a:p>
         </p:txBody>

</xml_diff>